<commit_message>
Add growth audit: Maiden Law Firm (June 5, 2026)
Corrected run 2: removed Elite Coach Plus per sales rep directive (Randy Gold) —
Phase 1 is Full Service Marketing Starter only. Updated section 11, executive
summary, Sales Companion PDF, and PPTX to reflect single-package recommendation.

Co-Authored-By: Claude Sonnet 4.6 <noreply@anthropic.com>
</commit_message>
<xml_diff>
--- a/maiden-law-firm/Maiden Law Firm_June 5, 2026_Proposal.pptx
+++ b/maiden-law-firm/Maiden Law Firm_June 5, 2026_Proposal.pptx
@@ -8957,306 +8957,6 @@
         </p:nvSpPr>
         <p:spPr>
           <a:xfrm>
-            <a:off x="201168" y="2139696"/>
-            <a:ext cx="4133087" cy="1024128"/>
-          </a:xfrm>
-          <a:prstGeom prst="rect">
-            <a:avLst/>
-          </a:prstGeom>
-          <a:solidFill>
-            <a:srgbClr val="FFFFFF"/>
-          </a:solidFill>
-          <a:ln>
-            <a:solidFill>
-              <a:srgbClr val="FFFFFF"/>
-            </a:solidFill>
-          </a:ln>
-        </p:spPr>
-        <p:style>
-          <a:lnRef idx="1">
-            <a:schemeClr val="accent1"/>
-          </a:lnRef>
-          <a:fillRef idx="3">
-            <a:schemeClr val="accent1"/>
-          </a:fillRef>
-          <a:effectRef idx="2">
-            <a:schemeClr val="accent1"/>
-          </a:effectRef>
-          <a:fontRef idx="minor">
-            <a:schemeClr val="lt1"/>
-          </a:fontRef>
-        </p:style>
-        <p:txBody>
-          <a:bodyPr rtlCol="0" anchor="ctr"/>
-          <a:lstStyle/>
-          <a:p>
-            <a:pPr algn="ctr"/>
-          </a:p>
-        </p:txBody>
-      </p:sp>
-      <p:sp>
-        <p:nvSpPr>
-          <p:cNvPr id="14" name="Rectangle 13"/>
-          <p:cNvSpPr/>
-          <p:nvPr/>
-        </p:nvSpPr>
-        <p:spPr>
-          <a:xfrm>
-            <a:off x="201168" y="2139696"/>
-            <a:ext cx="182880" cy="1024128"/>
-          </a:xfrm>
-          <a:prstGeom prst="rect">
-            <a:avLst/>
-          </a:prstGeom>
-          <a:solidFill>
-            <a:srgbClr val="6D28D9"/>
-          </a:solidFill>
-          <a:ln>
-            <a:solidFill>
-              <a:srgbClr val="FFFFFF"/>
-            </a:solidFill>
-          </a:ln>
-        </p:spPr>
-        <p:style>
-          <a:lnRef idx="1">
-            <a:schemeClr val="accent1"/>
-          </a:lnRef>
-          <a:fillRef idx="3">
-            <a:schemeClr val="accent1"/>
-          </a:fillRef>
-          <a:effectRef idx="2">
-            <a:schemeClr val="accent1"/>
-          </a:effectRef>
-          <a:fontRef idx="minor">
-            <a:schemeClr val="lt1"/>
-          </a:fontRef>
-        </p:style>
-        <p:txBody>
-          <a:bodyPr rtlCol="0" anchor="ctr"/>
-          <a:lstStyle/>
-          <a:p>
-            <a:pPr algn="ctr"/>
-          </a:p>
-        </p:txBody>
-      </p:sp>
-      <p:sp>
-        <p:nvSpPr>
-          <p:cNvPr id="15" name="TextBox 14"/>
-          <p:cNvSpPr txBox="1"/>
-          <p:nvPr/>
-        </p:nvSpPr>
-        <p:spPr>
-          <a:xfrm>
-            <a:off x="475488" y="2231136"/>
-            <a:ext cx="3803904" cy="201168"/>
-          </a:xfrm>
-          <a:prstGeom prst="rect">
-            <a:avLst/>
-          </a:prstGeom>
-          <a:noFill/>
-        </p:spPr>
-        <p:txBody>
-          <a:bodyPr wrap="square"/>
-          <a:lstStyle/>
-          <a:p>
-            <a:pPr algn="l"/>
-            <a:r>
-              <a:rPr sz="800" b="1" i="0">
-                <a:solidFill>
-                  <a:srgbClr val="6D28D9"/>
-                </a:solidFill>
-                <a:latin typeface="Calibri"/>
-              </a:rPr>
-              <a:t>ELITE COACH PLUS</a:t>
-            </a:r>
-          </a:p>
-        </p:txBody>
-      </p:sp>
-      <p:sp>
-        <p:nvSpPr>
-          <p:cNvPr id="16" name="TextBox 15"/>
-          <p:cNvSpPr txBox="1"/>
-          <p:nvPr/>
-        </p:nvSpPr>
-        <p:spPr>
-          <a:xfrm>
-            <a:off x="475488" y="2414015"/>
-            <a:ext cx="1828800" cy="438912"/>
-          </a:xfrm>
-          <a:prstGeom prst="rect">
-            <a:avLst/>
-          </a:prstGeom>
-          <a:noFill/>
-        </p:spPr>
-        <p:txBody>
-          <a:bodyPr wrap="square"/>
-          <a:lstStyle/>
-          <a:p>
-            <a:pPr algn="l"/>
-            <a:r>
-              <a:rPr sz="3200" b="1" i="0">
-                <a:solidFill>
-                  <a:srgbClr val="0D1F3C"/>
-                </a:solidFill>
-                <a:latin typeface="Calibri"/>
-              </a:rPr>
-              <a:t>$3,200</a:t>
-            </a:r>
-          </a:p>
-        </p:txBody>
-      </p:sp>
-      <p:sp>
-        <p:nvSpPr>
-          <p:cNvPr id="17" name="TextBox 16"/>
-          <p:cNvSpPr txBox="1"/>
-          <p:nvPr/>
-        </p:nvSpPr>
-        <p:spPr>
-          <a:xfrm>
-            <a:off x="1865376" y="2523744"/>
-            <a:ext cx="420624" cy="256032"/>
-          </a:xfrm>
-          <a:prstGeom prst="rect">
-            <a:avLst/>
-          </a:prstGeom>
-          <a:noFill/>
-        </p:spPr>
-        <p:txBody>
-          <a:bodyPr wrap="square"/>
-          <a:lstStyle/>
-          <a:p>
-            <a:pPr algn="l"/>
-            <a:r>
-              <a:rPr sz="1100" b="0" i="0">
-                <a:solidFill>
-                  <a:srgbClr val="64748B"/>
-                </a:solidFill>
-                <a:latin typeface="Calibri"/>
-              </a:rPr>
-              <a:t>/mo</a:t>
-            </a:r>
-          </a:p>
-        </p:txBody>
-      </p:sp>
-      <p:sp>
-        <p:nvSpPr>
-          <p:cNvPr id="18" name="TextBox 17"/>
-          <p:cNvSpPr txBox="1"/>
-          <p:nvPr/>
-        </p:nvSpPr>
-        <p:spPr>
-          <a:xfrm>
-            <a:off x="2322576" y="2542032"/>
-            <a:ext cx="914400" cy="237744"/>
-          </a:xfrm>
-          <a:prstGeom prst="rect">
-            <a:avLst/>
-          </a:prstGeom>
-          <a:noFill/>
-        </p:spPr>
-        <p:txBody>
-          <a:bodyPr wrap="square"/>
-          <a:lstStyle/>
-          <a:p>
-            <a:pPr algn="l"/>
-            <a:r>
-              <a:rPr sz="1100" b="0" i="0">
-                <a:solidFill>
-                  <a:srgbClr val="334155"/>
-                </a:solidFill>
-                <a:latin typeface="Calibri"/>
-              </a:rPr>
-              <a:t>$3,497/mo</a:t>
-            </a:r>
-          </a:p>
-        </p:txBody>
-      </p:sp>
-      <p:sp>
-        <p:nvSpPr>
-          <p:cNvPr id="19" name="Rectangle 18"/>
-          <p:cNvSpPr/>
-          <p:nvPr/>
-        </p:nvSpPr>
-        <p:spPr>
-          <a:xfrm>
-            <a:off x="2322576" y="2642615"/>
-            <a:ext cx="804672" cy="9144"/>
-          </a:xfrm>
-          <a:prstGeom prst="rect">
-            <a:avLst/>
-          </a:prstGeom>
-          <a:solidFill>
-            <a:srgbClr val="334155"/>
-          </a:solidFill>
-          <a:ln>
-            <a:solidFill>
-              <a:srgbClr val="FFFFFF"/>
-            </a:solidFill>
-          </a:ln>
-        </p:spPr>
-        <p:style>
-          <a:lnRef idx="1">
-            <a:schemeClr val="accent1"/>
-          </a:lnRef>
-          <a:fillRef idx="3">
-            <a:schemeClr val="accent1"/>
-          </a:fillRef>
-          <a:effectRef idx="2">
-            <a:schemeClr val="accent1"/>
-          </a:effectRef>
-          <a:fontRef idx="minor">
-            <a:schemeClr val="lt1"/>
-          </a:fontRef>
-        </p:style>
-        <p:txBody>
-          <a:bodyPr rtlCol="0" anchor="ctr"/>
-          <a:lstStyle/>
-          <a:p>
-            <a:pPr algn="ctr"/>
-          </a:p>
-        </p:txBody>
-      </p:sp>
-      <p:sp>
-        <p:nvSpPr>
-          <p:cNvPr id="20" name="TextBox 19"/>
-          <p:cNvSpPr txBox="1"/>
-          <p:nvPr/>
-        </p:nvSpPr>
-        <p:spPr>
-          <a:xfrm>
-            <a:off x="475488" y="2907791"/>
-            <a:ext cx="3803904" cy="201168"/>
-          </a:xfrm>
-          <a:prstGeom prst="rect">
-            <a:avLst/>
-          </a:prstGeom>
-          <a:noFill/>
-        </p:spPr>
-        <p:txBody>
-          <a:bodyPr wrap="square"/>
-          <a:lstStyle/>
-          <a:p>
-            <a:pPr algn="l"/>
-            <a:r>
-              <a:rPr sz="800" b="0" i="0">
-                <a:solidFill>
-                  <a:srgbClr val="64748B"/>
-                </a:solidFill>
-                <a:latin typeface="Calibri"/>
-              </a:rPr>
-              <a:t>Dedicated coach · Weekly coaching · Intake + team systems</a:t>
-            </a:r>
-          </a:p>
-        </p:txBody>
-      </p:sp>
-      <p:sp>
-        <p:nvSpPr>
-          <p:cNvPr id="21" name="Rectangle 20"/>
-          <p:cNvSpPr/>
-          <p:nvPr/>
-        </p:nvSpPr>
-        <p:spPr>
-          <a:xfrm>
             <a:off x="201168" y="3255264"/>
             <a:ext cx="4133087" cy="658368"/>
           </a:xfrm>
@@ -9296,7 +8996,7 @@
       </p:sp>
       <p:sp>
         <p:nvSpPr>
-          <p:cNvPr id="22" name="TextBox 21"/>
+          <p:cNvPr id="14" name="TextBox 13"/>
           <p:cNvSpPr txBox="1"/>
           <p:nvPr/>
         </p:nvSpPr>
@@ -9329,7 +9029,7 @@
       </p:sp>
       <p:sp>
         <p:nvSpPr>
-          <p:cNvPr id="23" name="TextBox 22"/>
+          <p:cNvPr id="15" name="TextBox 14"/>
           <p:cNvSpPr txBox="1"/>
           <p:nvPr/>
         </p:nvSpPr>
@@ -9355,14 +9055,14 @@
                 </a:solidFill>
                 <a:latin typeface="Calibri"/>
               </a:rPr>
-              <a:t>$8,047 / mo</a:t>
-            </a:r>
-          </a:p>
-        </p:txBody>
-      </p:sp>
-      <p:sp>
-        <p:nvSpPr>
-          <p:cNvPr id="24" name="TextBox 23"/>
+              <a:t>$4,847 / mo</a:t>
+            </a:r>
+          </a:p>
+        </p:txBody>
+      </p:sp>
+      <p:sp>
+        <p:nvSpPr>
+          <p:cNvPr id="16" name="TextBox 15"/>
           <p:cNvSpPr txBox="1"/>
           <p:nvPr/>
         </p:nvSpPr>
@@ -9388,14 +9088,14 @@
                 </a:solidFill>
                 <a:latin typeface="Calibri"/>
               </a:rPr>
-              <a:t>Save $1,147/mo by bundling</a:t>
-            </a:r>
-          </a:p>
-        </p:txBody>
-      </p:sp>
-      <p:sp>
-        <p:nvSpPr>
-          <p:cNvPr id="25" name="Rectangle 24"/>
+              <a:t>Save $850/mo vs. stand-alone</a:t>
+            </a:r>
+          </a:p>
+        </p:txBody>
+      </p:sp>
+      <p:sp>
+        <p:nvSpPr>
+          <p:cNvPr id="17" name="Rectangle 16"/>
           <p:cNvSpPr/>
           <p:nvPr/>
         </p:nvSpPr>
@@ -9440,7 +9140,7 @@
       </p:sp>
       <p:sp>
         <p:nvSpPr>
-          <p:cNvPr id="26" name="TextBox 25"/>
+          <p:cNvPr id="18" name="TextBox 17"/>
           <p:cNvSpPr txBox="1"/>
           <p:nvPr/>
         </p:nvSpPr>
@@ -9473,7 +9173,7 @@
       </p:sp>
       <p:sp>
         <p:nvSpPr>
-          <p:cNvPr id="27" name="Rectangle 26"/>
+          <p:cNvPr id="19" name="Rectangle 18"/>
           <p:cNvSpPr/>
           <p:nvPr/>
         </p:nvSpPr>
@@ -9518,7 +9218,7 @@
       </p:sp>
       <p:sp>
         <p:nvSpPr>
-          <p:cNvPr id="28" name="TextBox 27"/>
+          <p:cNvPr id="20" name="TextBox 19"/>
           <p:cNvSpPr txBox="1"/>
           <p:nvPr/>
         </p:nvSpPr>
@@ -9551,7 +9251,7 @@
       </p:sp>
       <p:sp>
         <p:nvSpPr>
-          <p:cNvPr id="29" name="TextBox 28"/>
+          <p:cNvPr id="21" name="TextBox 20"/>
           <p:cNvSpPr txBox="1"/>
           <p:nvPr/>
         </p:nvSpPr>
@@ -9584,7 +9284,7 @@
       </p:sp>
       <p:sp>
         <p:nvSpPr>
-          <p:cNvPr id="30" name="TextBox 29"/>
+          <p:cNvPr id="22" name="TextBox 21"/>
           <p:cNvSpPr txBox="1"/>
           <p:nvPr/>
         </p:nvSpPr>
@@ -9617,7 +9317,7 @@
       </p:sp>
       <p:sp>
         <p:nvSpPr>
-          <p:cNvPr id="31" name="Rectangle 30"/>
+          <p:cNvPr id="23" name="Rectangle 22"/>
           <p:cNvSpPr/>
           <p:nvPr/>
         </p:nvSpPr>
@@ -9662,7 +9362,7 @@
       </p:sp>
       <p:sp>
         <p:nvSpPr>
-          <p:cNvPr id="32" name="TextBox 31"/>
+          <p:cNvPr id="24" name="TextBox 23"/>
           <p:cNvSpPr txBox="1"/>
           <p:nvPr/>
         </p:nvSpPr>
@@ -9695,7 +9395,7 @@
       </p:sp>
       <p:sp>
         <p:nvSpPr>
-          <p:cNvPr id="33" name="TextBox 32"/>
+          <p:cNvPr id="25" name="TextBox 24"/>
           <p:cNvSpPr txBox="1"/>
           <p:nvPr/>
         </p:nvSpPr>
@@ -9728,7 +9428,7 @@
       </p:sp>
       <p:sp>
         <p:nvSpPr>
-          <p:cNvPr id="34" name="TextBox 33"/>
+          <p:cNvPr id="26" name="TextBox 25"/>
           <p:cNvSpPr txBox="1"/>
           <p:nvPr/>
         </p:nvSpPr>
@@ -9761,7 +9461,7 @@
       </p:sp>
       <p:sp>
         <p:nvSpPr>
-          <p:cNvPr id="35" name="TextBox 34"/>
+          <p:cNvPr id="27" name="TextBox 26"/>
           <p:cNvSpPr txBox="1"/>
           <p:nvPr/>
         </p:nvSpPr>
@@ -9794,7 +9494,7 @@
       </p:sp>
       <p:sp>
         <p:nvSpPr>
-          <p:cNvPr id="36" name="TextBox 35"/>
+          <p:cNvPr id="28" name="TextBox 27"/>
           <p:cNvSpPr txBox="1"/>
           <p:nvPr/>
         </p:nvSpPr>
@@ -9827,7 +9527,7 @@
       </p:sp>
       <p:sp>
         <p:nvSpPr>
-          <p:cNvPr id="37" name="Rectangle 36"/>
+          <p:cNvPr id="29" name="Rectangle 28"/>
           <p:cNvSpPr/>
           <p:nvPr/>
         </p:nvSpPr>
@@ -9872,7 +9572,7 @@
       </p:sp>
       <p:sp>
         <p:nvSpPr>
-          <p:cNvPr id="38" name="TextBox 37"/>
+          <p:cNvPr id="30" name="TextBox 29"/>
           <p:cNvSpPr txBox="1"/>
           <p:nvPr/>
         </p:nvSpPr>
@@ -9905,7 +9605,7 @@
       </p:sp>
       <p:sp>
         <p:nvSpPr>
-          <p:cNvPr id="39" name="TextBox 38"/>
+          <p:cNvPr id="31" name="TextBox 30"/>
           <p:cNvSpPr txBox="1"/>
           <p:nvPr/>
         </p:nvSpPr>
@@ -9938,7 +9638,7 @@
       </p:sp>
       <p:sp>
         <p:nvSpPr>
-          <p:cNvPr id="40" name="Rectangle 39"/>
+          <p:cNvPr id="32" name="Rectangle 31"/>
           <p:cNvSpPr/>
           <p:nvPr/>
         </p:nvSpPr>
@@ -9983,7 +9683,7 @@
       </p:sp>
       <p:sp>
         <p:nvSpPr>
-          <p:cNvPr id="41" name="TextBox 40"/>
+          <p:cNvPr id="33" name="TextBox 32"/>
           <p:cNvSpPr txBox="1"/>
           <p:nvPr/>
         </p:nvSpPr>
@@ -10016,7 +9716,7 @@
       </p:sp>
       <p:sp>
         <p:nvSpPr>
-          <p:cNvPr id="42" name="TextBox 41"/>
+          <p:cNvPr id="34" name="TextBox 33"/>
           <p:cNvSpPr txBox="1"/>
           <p:nvPr/>
         </p:nvSpPr>
@@ -10049,7 +9749,7 @@
       </p:sp>
       <p:sp>
         <p:nvSpPr>
-          <p:cNvPr id="43" name="Rectangle 42"/>
+          <p:cNvPr id="35" name="Rectangle 34"/>
           <p:cNvSpPr/>
           <p:nvPr/>
         </p:nvSpPr>
@@ -10094,7 +9794,7 @@
       </p:sp>
       <p:sp>
         <p:nvSpPr>
-          <p:cNvPr id="44" name="TextBox 43"/>
+          <p:cNvPr id="36" name="TextBox 35"/>
           <p:cNvSpPr txBox="1"/>
           <p:nvPr/>
         </p:nvSpPr>
@@ -10120,14 +9820,14 @@
                 </a:solidFill>
                 <a:latin typeface="Calibri"/>
               </a:rPr>
-              <a:t>Week 6</a:t>
-            </a:r>
-          </a:p>
-        </p:txBody>
-      </p:sp>
-      <p:sp>
-        <p:nvSpPr>
-          <p:cNvPr id="45" name="TextBox 44"/>
+              <a:t>Week 4</a:t>
+            </a:r>
+          </a:p>
+        </p:txBody>
+      </p:sp>
+      <p:sp>
+        <p:nvSpPr>
+          <p:cNvPr id="37" name="TextBox 36"/>
           <p:cNvSpPr txBox="1"/>
           <p:nvPr/>
         </p:nvSpPr>
@@ -10153,14 +9853,14 @@
                 </a:solidFill>
                 <a:latin typeface="Calibri"/>
               </a:rPr>
-              <a:t>Website rebuild — bio, practice pages, city pages</a:t>
-            </a:r>
-          </a:p>
-        </p:txBody>
-      </p:sp>
-      <p:sp>
-        <p:nvSpPr>
-          <p:cNvPr id="46" name="Rectangle 45"/>
+              <a:t>Review request campaign begins — targeting 50+ in 90 days</a:t>
+            </a:r>
+          </a:p>
+        </p:txBody>
+      </p:sp>
+      <p:sp>
+        <p:nvSpPr>
+          <p:cNvPr id="38" name="Rectangle 37"/>
           <p:cNvSpPr/>
           <p:nvPr/>
         </p:nvSpPr>
@@ -10205,7 +9905,7 @@
       </p:sp>
       <p:sp>
         <p:nvSpPr>
-          <p:cNvPr id="47" name="TextBox 46"/>
+          <p:cNvPr id="39" name="TextBox 38"/>
           <p:cNvSpPr txBox="1"/>
           <p:nvPr/>
         </p:nvSpPr>
@@ -10231,14 +9931,14 @@
                 </a:solidFill>
                 <a:latin typeface="Calibri"/>
               </a:rPr>
-              <a:t>Week 8</a:t>
-            </a:r>
-          </a:p>
-        </p:txBody>
-      </p:sp>
-      <p:sp>
-        <p:nvSpPr>
-          <p:cNvPr id="48" name="TextBox 47"/>
+              <a:t>Week 6</a:t>
+            </a:r>
+          </a:p>
+        </p:txBody>
+      </p:sp>
+      <p:sp>
+        <p:nvSpPr>
+          <p:cNvPr id="40" name="TextBox 39"/>
           <p:cNvSpPr txBox="1"/>
           <p:nvPr/>
         </p:nvSpPr>
@@ -10264,14 +9964,14 @@
                 </a:solidFill>
                 <a:latin typeface="Calibri"/>
               </a:rPr>
-              <a:t>Elite Coach kickoff — intake protocols defined</a:t>
-            </a:r>
-          </a:p>
-        </p:txBody>
-      </p:sp>
-      <p:sp>
-        <p:nvSpPr>
-          <p:cNvPr id="49" name="Rectangle 48"/>
+              <a:t>Website rebuild — bio, practice pages, city pages</a:t>
+            </a:r>
+          </a:p>
+        </p:txBody>
+      </p:sp>
+      <p:sp>
+        <p:nvSpPr>
+          <p:cNvPr id="41" name="Rectangle 40"/>
           <p:cNvSpPr/>
           <p:nvPr/>
         </p:nvSpPr>
@@ -10316,7 +10016,7 @@
       </p:sp>
       <p:sp>
         <p:nvSpPr>
-          <p:cNvPr id="50" name="TextBox 49"/>
+          <p:cNvPr id="42" name="TextBox 41"/>
           <p:cNvSpPr txBox="1"/>
           <p:nvPr/>
         </p:nvSpPr>
@@ -10349,7 +10049,7 @@
       </p:sp>
       <p:sp>
         <p:nvSpPr>
-          <p:cNvPr id="51" name="TextBox 50"/>
+          <p:cNvPr id="43" name="TextBox 42"/>
           <p:cNvSpPr txBox="1"/>
           <p:nvPr/>
         </p:nvSpPr>
@@ -10382,7 +10082,7 @@
       </p:sp>
       <p:sp>
         <p:nvSpPr>
-          <p:cNvPr id="52" name="Rectangle 51"/>
+          <p:cNvPr id="44" name="Rectangle 43"/>
           <p:cNvSpPr/>
           <p:nvPr/>
         </p:nvSpPr>
@@ -10427,7 +10127,7 @@
       </p:sp>
       <p:sp>
         <p:nvSpPr>
-          <p:cNvPr id="53" name="TextBox 52"/>
+          <p:cNvPr id="45" name="TextBox 44"/>
           <p:cNvSpPr txBox="1"/>
           <p:nvPr/>
         </p:nvSpPr>
@@ -10460,7 +10160,7 @@
       </p:sp>
       <p:sp>
         <p:nvSpPr>
-          <p:cNvPr id="54" name="Rectangle 53"/>
+          <p:cNvPr id="46" name="Rectangle 45"/>
           <p:cNvSpPr/>
           <p:nvPr/>
         </p:nvSpPr>
@@ -10505,7 +10205,7 @@
       </p:sp>
       <p:sp>
         <p:nvSpPr>
-          <p:cNvPr id="55" name="TextBox 54"/>
+          <p:cNvPr id="47" name="TextBox 46"/>
           <p:cNvSpPr txBox="1"/>
           <p:nvPr/>
         </p:nvSpPr>
@@ -10538,7 +10238,7 @@
       </p:sp>
       <p:sp>
         <p:nvSpPr>
-          <p:cNvPr id="56" name="TextBox 55"/>
+          <p:cNvPr id="48" name="TextBox 47"/>
           <p:cNvSpPr txBox="1"/>
           <p:nvPr/>
         </p:nvSpPr>

</xml_diff>